<commit_message>
fix: reuse existing a:ln element in _arrow_v to make arrow heads render
conn.line.color.rgb already creates an a:ln child inside spPr.
Adding a second a:ln with etree.SubElement caused the tailEnd arrow
element to be on a duplicate ln that PowerPoint ignores, so no arrow
heads appeared on connectors.

Fix: find the existing a:ln (or create one if absent) before appending
the tailEnd child. Regenerated gate_review_precursor.pptx accordingly.

Co-Authored-By: Claude Sonnet 4.6 <noreply@anthropic.com>
</commit_message>
<xml_diff>
--- a/gate_review_precursor.pptx
+++ b/gate_review_precursor.pptx
@@ -4222,7 +4222,7 @@
                 </a:solidFill>
                 <a:latin typeface="맑은 고딕"/>
               </a:rPr>
-              <a:t>    –    --preset acicular_20k  --lsd_fuse_segments</a:t>
+              <a:t>    –    --preset acicular_20k</a:t>
             </a:r>
           </a:p>
           <a:p>
@@ -5444,8 +5444,6 @@
             <a:solidFill>
               <a:srgbClr val="888888"/>
             </a:solidFill>
-          </a:ln>
-          <a:ln>
             <a:tailEnd type="arrow" w="med" len="med"/>
           </a:ln>
         </p:spPr>
@@ -5557,8 +5555,6 @@
             <a:solidFill>
               <a:srgbClr val="888888"/>
             </a:solidFill>
-          </a:ln>
-          <a:ln>
             <a:tailEnd type="arrow" w="med" len="med"/>
           </a:ln>
         </p:spPr>
@@ -5670,8 +5666,6 @@
             <a:solidFill>
               <a:srgbClr val="888888"/>
             </a:solidFill>
-          </a:ln>
-          <a:ln>
             <a:tailEnd type="arrow" w="med" len="med"/>
           </a:ln>
         </p:spPr>
@@ -5783,8 +5777,6 @@
             <a:solidFill>
               <a:srgbClr val="888888"/>
             </a:solidFill>
-          </a:ln>
-          <a:ln>
             <a:tailEnd type="arrow" w="med" len="med"/>
           </a:ln>
         </p:spPr>
@@ -7861,22 +7853,6 @@
                 <a:latin typeface="맑은 고딕"/>
               </a:rPr>
               <a:t>▪  빨강/파랑 선분: 검출된 침상 선분  |  각 선분에 두께(µm) 라벨 표시</a:t>
-            </a:r>
-          </a:p>
-          <a:p>
-            <a:pPr>
-              <a:spcBef>
-                <a:spcPts val="300"/>
-              </a:spcBef>
-            </a:pPr>
-            <a:r>
-              <a:rPr sz="1200">
-                <a:solidFill>
-                  <a:srgbClr val="2B2B2B"/>
-                </a:solidFill>
-                <a:latin typeface="맑은 고딕"/>
-              </a:rPr>
-              <a:t>▪  선분 융합(--lsd_fuse_segments, 기본 ON): 같은 침상이 여러 조각으로 검출될 때 하나로 통합</a:t>
             </a:r>
           </a:p>
           <a:p>
@@ -10566,7 +10542,7 @@
                 </a:solidFill>
                 <a:latin typeface="맑은 고딕"/>
               </a:rPr>
-              <a:t>--lsd_fuse_segments</a:t>
+              <a:t>--lsd_adaptive_thresh</a:t>
             </a:r>
           </a:p>
         </p:txBody>
@@ -10646,7 +10622,7 @@
                 </a:solidFill>
                 <a:latin typeface="맑은 고딕"/>
               </a:rPr>
-              <a:t>[ ON (기본값) 결과 이미지 ]</a:t>
+              <a:t>[ OFF (기본값) 결과 이미지 ]</a:t>
             </a:r>
           </a:p>
         </p:txBody>
@@ -10704,7 +10680,7 @@
                 </a:solidFill>
                 <a:latin typeface="맑은 고딕"/>
               </a:rPr>
-              <a:t>ON (기본값)</a:t>
+              <a:t>OFF (기본값)</a:t>
             </a:r>
           </a:p>
         </p:txBody>
@@ -10784,7 +10760,7 @@
                 </a:solidFill>
                 <a:latin typeface="맑은 고딕"/>
               </a:rPr>
-              <a:t>[ OFF 결과 이미지 ]</a:t>
+              <a:t>[ ON 결과 이미지 ]</a:t>
             </a:r>
           </a:p>
         </p:txBody>
@@ -10842,7 +10818,7 @@
                 </a:solidFill>
                 <a:latin typeface="맑은 고딕"/>
               </a:rPr>
-              <a:t>OFF</a:t>
+              <a:t>ON</a:t>
             </a:r>
           </a:p>
         </p:txBody>
@@ -10856,373 +10832,6 @@
         <p:spPr>
           <a:xfrm>
             <a:off x="320040" y="3246120"/>
-            <a:ext cx="11521440" cy="347472"/>
-          </a:xfrm>
-          <a:prstGeom prst="rect">
-            <a:avLst/>
-          </a:prstGeom>
-          <a:noFill/>
-        </p:spPr>
-        <p:txBody>
-          <a:bodyPr wrap="square">
-            <a:spAutoFit/>
-          </a:bodyPr>
-          <a:lstStyle/>
-          <a:p>
-            <a:pPr algn="l"/>
-            <a:r>
-              <a:rPr sz="1200" b="0">
-                <a:solidFill>
-                  <a:srgbClr val="1B3A6B"/>
-                </a:solidFill>
-                <a:latin typeface="맑은 고딕"/>
-              </a:rPr>
-              <a:t>▷  같은 침상이 여러 선분으로 검출될 때 융합 → 장축 길이 과소평가 방지</a:t>
-            </a:r>
-          </a:p>
-        </p:txBody>
-      </p:sp>
-      <p:sp>
-        <p:nvSpPr>
-          <p:cNvPr id="17" name="Rectangle 16"/>
-          <p:cNvSpPr/>
-          <p:nvPr/>
-        </p:nvSpPr>
-        <p:spPr>
-          <a:xfrm>
-            <a:off x="320040" y="3703320"/>
-            <a:ext cx="3200400" cy="438912"/>
-          </a:xfrm>
-          <a:prstGeom prst="rect">
-            <a:avLst/>
-          </a:prstGeom>
-          <a:solidFill>
-            <a:srgbClr val="1B3A6B"/>
-          </a:solidFill>
-          <a:ln>
-            <a:noFill/>
-          </a:ln>
-        </p:spPr>
-        <p:style>
-          <a:lnRef idx="1">
-            <a:schemeClr val="accent1"/>
-          </a:lnRef>
-          <a:fillRef idx="3">
-            <a:schemeClr val="accent1"/>
-          </a:fillRef>
-          <a:effectRef idx="2">
-            <a:schemeClr val="accent1"/>
-          </a:effectRef>
-          <a:fontRef idx="minor">
-            <a:schemeClr val="lt1"/>
-          </a:fontRef>
-        </p:style>
-        <p:txBody>
-          <a:bodyPr rtlCol="0" anchor="ctr" wrap="square"/>
-          <a:lstStyle/>
-          <a:p>
-            <a:pPr algn="ctr">
-              <a:spcBef>
-                <a:spcPts val="200"/>
-              </a:spcBef>
-            </a:pPr>
-            <a:r>
-              <a:rPr sz="1300" b="1">
-                <a:solidFill>
-                  <a:srgbClr val="FFFFFF"/>
-                </a:solidFill>
-                <a:latin typeface="맑은 고딕"/>
-              </a:rPr>
-              <a:t>--lsd_adaptive_thresh</a:t>
-            </a:r>
-          </a:p>
-        </p:txBody>
-      </p:sp>
-      <p:sp>
-        <p:nvSpPr>
-          <p:cNvPr id="18" name="Rectangle 17"/>
-          <p:cNvSpPr/>
-          <p:nvPr/>
-        </p:nvSpPr>
-        <p:spPr>
-          <a:xfrm>
-            <a:off x="3657600" y="3703320"/>
-            <a:ext cx="4114800" cy="1828800"/>
-          </a:xfrm>
-          <a:prstGeom prst="rect">
-            <a:avLst/>
-          </a:prstGeom>
-          <a:solidFill>
-            <a:srgbClr val="F0F2F5"/>
-          </a:solidFill>
-          <a:ln w="12700">
-            <a:solidFill>
-              <a:srgbClr val="1B3A6B"/>
-            </a:solidFill>
-          </a:ln>
-        </p:spPr>
-        <p:style>
-          <a:lnRef idx="1">
-            <a:schemeClr val="accent1"/>
-          </a:lnRef>
-          <a:fillRef idx="3">
-            <a:schemeClr val="accent1"/>
-          </a:fillRef>
-          <a:effectRef idx="2">
-            <a:schemeClr val="accent1"/>
-          </a:effectRef>
-          <a:fontRef idx="minor">
-            <a:schemeClr val="lt1"/>
-          </a:fontRef>
-        </p:style>
-        <p:txBody>
-          <a:bodyPr rtlCol="0" anchor="ctr"/>
-          <a:lstStyle/>
-          <a:p>
-            <a:pPr algn="ctr"/>
-          </a:p>
-        </p:txBody>
-      </p:sp>
-      <p:sp>
-        <p:nvSpPr>
-          <p:cNvPr id="19" name="TextBox 18"/>
-          <p:cNvSpPr txBox="1"/>
-          <p:nvPr/>
-        </p:nvSpPr>
-        <p:spPr>
-          <a:xfrm>
-            <a:off x="4114800" y="4480560"/>
-            <a:ext cx="3200400" cy="457200"/>
-          </a:xfrm>
-          <a:prstGeom prst="rect">
-            <a:avLst/>
-          </a:prstGeom>
-          <a:noFill/>
-        </p:spPr>
-        <p:txBody>
-          <a:bodyPr wrap="square">
-            <a:spAutoFit/>
-          </a:bodyPr>
-          <a:lstStyle/>
-          <a:p>
-            <a:pPr algn="ctr"/>
-            <a:r>
-              <a:rPr sz="1100" b="0">
-                <a:solidFill>
-                  <a:srgbClr val="888888"/>
-                </a:solidFill>
-                <a:latin typeface="맑은 고딕"/>
-              </a:rPr>
-              <a:t>[ OFF (기본값) 결과 이미지 ]</a:t>
-            </a:r>
-          </a:p>
-        </p:txBody>
-      </p:sp>
-      <p:sp>
-        <p:nvSpPr>
-          <p:cNvPr id="20" name="Rectangle 19"/>
-          <p:cNvSpPr/>
-          <p:nvPr/>
-        </p:nvSpPr>
-        <p:spPr>
-          <a:xfrm>
-            <a:off x="3657600" y="3703320"/>
-            <a:ext cx="4114800" cy="365760"/>
-          </a:xfrm>
-          <a:prstGeom prst="rect">
-            <a:avLst/>
-          </a:prstGeom>
-          <a:solidFill>
-            <a:srgbClr val="D6E4F7"/>
-          </a:solidFill>
-          <a:ln w="19050">
-            <a:solidFill>
-              <a:srgbClr val="1B3A6B"/>
-            </a:solidFill>
-          </a:ln>
-        </p:spPr>
-        <p:style>
-          <a:lnRef idx="1">
-            <a:schemeClr val="accent1"/>
-          </a:lnRef>
-          <a:fillRef idx="3">
-            <a:schemeClr val="accent1"/>
-          </a:fillRef>
-          <a:effectRef idx="2">
-            <a:schemeClr val="accent1"/>
-          </a:effectRef>
-          <a:fontRef idx="minor">
-            <a:schemeClr val="lt1"/>
-          </a:fontRef>
-        </p:style>
-        <p:txBody>
-          <a:bodyPr rtlCol="0" anchor="ctr" wrap="square"/>
-          <a:lstStyle/>
-          <a:p>
-            <a:pPr algn="ctr">
-              <a:spcBef>
-                <a:spcPts val="200"/>
-              </a:spcBef>
-            </a:pPr>
-            <a:r>
-              <a:rPr sz="1100" b="1">
-                <a:solidFill>
-                  <a:srgbClr val="1B3A6B"/>
-                </a:solidFill>
-                <a:latin typeface="맑은 고딕"/>
-              </a:rPr>
-              <a:t>OFF (기본값)</a:t>
-            </a:r>
-          </a:p>
-        </p:txBody>
-      </p:sp>
-      <p:sp>
-        <p:nvSpPr>
-          <p:cNvPr id="21" name="Rectangle 20"/>
-          <p:cNvSpPr/>
-          <p:nvPr/>
-        </p:nvSpPr>
-        <p:spPr>
-          <a:xfrm>
-            <a:off x="8092440" y="3703320"/>
-            <a:ext cx="4114800" cy="1828800"/>
-          </a:xfrm>
-          <a:prstGeom prst="rect">
-            <a:avLst/>
-          </a:prstGeom>
-          <a:solidFill>
-            <a:srgbClr val="F0F2F5"/>
-          </a:solidFill>
-          <a:ln w="12700">
-            <a:solidFill>
-              <a:srgbClr val="1B3A6B"/>
-            </a:solidFill>
-          </a:ln>
-        </p:spPr>
-        <p:style>
-          <a:lnRef idx="1">
-            <a:schemeClr val="accent1"/>
-          </a:lnRef>
-          <a:fillRef idx="3">
-            <a:schemeClr val="accent1"/>
-          </a:fillRef>
-          <a:effectRef idx="2">
-            <a:schemeClr val="accent1"/>
-          </a:effectRef>
-          <a:fontRef idx="minor">
-            <a:schemeClr val="lt1"/>
-          </a:fontRef>
-        </p:style>
-        <p:txBody>
-          <a:bodyPr rtlCol="0" anchor="ctr"/>
-          <a:lstStyle/>
-          <a:p>
-            <a:pPr algn="ctr"/>
-          </a:p>
-        </p:txBody>
-      </p:sp>
-      <p:sp>
-        <p:nvSpPr>
-          <p:cNvPr id="22" name="TextBox 21"/>
-          <p:cNvSpPr txBox="1"/>
-          <p:nvPr/>
-        </p:nvSpPr>
-        <p:spPr>
-          <a:xfrm>
-            <a:off x="8549640" y="4480560"/>
-            <a:ext cx="3200400" cy="457200"/>
-          </a:xfrm>
-          <a:prstGeom prst="rect">
-            <a:avLst/>
-          </a:prstGeom>
-          <a:noFill/>
-        </p:spPr>
-        <p:txBody>
-          <a:bodyPr wrap="square">
-            <a:spAutoFit/>
-          </a:bodyPr>
-          <a:lstStyle/>
-          <a:p>
-            <a:pPr algn="ctr"/>
-            <a:r>
-              <a:rPr sz="1100" b="0">
-                <a:solidFill>
-                  <a:srgbClr val="888888"/>
-                </a:solidFill>
-                <a:latin typeface="맑은 고딕"/>
-              </a:rPr>
-              <a:t>[ ON 결과 이미지 ]</a:t>
-            </a:r>
-          </a:p>
-        </p:txBody>
-      </p:sp>
-      <p:sp>
-        <p:nvSpPr>
-          <p:cNvPr id="23" name="Rectangle 22"/>
-          <p:cNvSpPr/>
-          <p:nvPr/>
-        </p:nvSpPr>
-        <p:spPr>
-          <a:xfrm>
-            <a:off x="8092440" y="3703320"/>
-            <a:ext cx="4114800" cy="365760"/>
-          </a:xfrm>
-          <a:prstGeom prst="rect">
-            <a:avLst/>
-          </a:prstGeom>
-          <a:solidFill>
-            <a:srgbClr val="FDE8D8"/>
-          </a:solidFill>
-          <a:ln w="19050">
-            <a:solidFill>
-              <a:srgbClr val="E85D26"/>
-            </a:solidFill>
-          </a:ln>
-        </p:spPr>
-        <p:style>
-          <a:lnRef idx="1">
-            <a:schemeClr val="accent1"/>
-          </a:lnRef>
-          <a:fillRef idx="3">
-            <a:schemeClr val="accent1"/>
-          </a:fillRef>
-          <a:effectRef idx="2">
-            <a:schemeClr val="accent1"/>
-          </a:effectRef>
-          <a:fontRef idx="minor">
-            <a:schemeClr val="lt1"/>
-          </a:fontRef>
-        </p:style>
-        <p:txBody>
-          <a:bodyPr rtlCol="0" anchor="ctr" wrap="square"/>
-          <a:lstStyle/>
-          <a:p>
-            <a:pPr algn="ctr">
-              <a:spcBef>
-                <a:spcPts val="200"/>
-              </a:spcBef>
-            </a:pPr>
-            <a:r>
-              <a:rPr sz="1100" b="1">
-                <a:solidFill>
-                  <a:srgbClr val="E85D26"/>
-                </a:solidFill>
-                <a:latin typeface="맑은 고딕"/>
-              </a:rPr>
-              <a:t>ON</a:t>
-            </a:r>
-          </a:p>
-        </p:txBody>
-      </p:sp>
-      <p:sp>
-        <p:nvSpPr>
-          <p:cNvPr id="24" name="TextBox 23"/>
-          <p:cNvSpPr txBox="1"/>
-          <p:nvPr/>
-        </p:nvSpPr>
-        <p:spPr>
-          <a:xfrm>
-            <a:off x="320040" y="5623560"/>
             <a:ext cx="11521440" cy="347472"/>
           </a:xfrm>
           <a:prstGeom prst="rect">
@@ -21272,8 +20881,6 @@
             <a:solidFill>
               <a:srgbClr val="888888"/>
             </a:solidFill>
-          </a:ln>
-          <a:ln>
             <a:tailEnd type="arrow" w="med" len="med"/>
           </a:ln>
         </p:spPr>
@@ -21368,8 +20975,6 @@
             <a:solidFill>
               <a:srgbClr val="888888"/>
             </a:solidFill>
-          </a:ln>
-          <a:ln>
             <a:tailEnd type="arrow" w="med" len="med"/>
           </a:ln>
         </p:spPr>
@@ -21464,8 +21069,6 @@
             <a:solidFill>
               <a:srgbClr val="888888"/>
             </a:solidFill>
-          </a:ln>
-          <a:ln>
             <a:tailEnd type="arrow" w="med" len="med"/>
           </a:ln>
         </p:spPr>
@@ -21576,8 +21179,6 @@
             <a:solidFill>
               <a:srgbClr val="888888"/>
             </a:solidFill>
-          </a:ln>
-          <a:ln>
             <a:tailEnd type="arrow" w="med" len="med"/>
           </a:ln>
         </p:spPr>
@@ -21688,8 +21289,6 @@
             <a:solidFill>
               <a:srgbClr val="888888"/>
             </a:solidFill>
-          </a:ln>
-          <a:ln>
             <a:tailEnd type="arrow" w="med" len="med"/>
           </a:ln>
         </p:spPr>
@@ -21800,8 +21399,6 @@
             <a:solidFill>
               <a:srgbClr val="888888"/>
             </a:solidFill>
-          </a:ln>
-          <a:ln>
             <a:tailEnd type="arrow" w="med" len="med"/>
           </a:ln>
         </p:spPr>
@@ -22026,8 +21623,6 @@
             <a:solidFill>
               <a:srgbClr val="E85D26"/>
             </a:solidFill>
-          </a:ln>
-          <a:ln>
             <a:tailEnd type="arrow" w="med" len="med"/>
           </a:ln>
         </p:spPr>
@@ -22122,8 +21717,6 @@
             <a:solidFill>
               <a:srgbClr val="E85D26"/>
             </a:solidFill>
-          </a:ln>
-          <a:ln>
             <a:tailEnd type="arrow" w="med" len="med"/>
           </a:ln>
         </p:spPr>
@@ -22218,8 +21811,6 @@
             <a:solidFill>
               <a:srgbClr val="E85D26"/>
             </a:solidFill>
-          </a:ln>
-          <a:ln>
             <a:tailEnd type="arrow" w="med" len="med"/>
           </a:ln>
         </p:spPr>
@@ -22330,8 +21921,6 @@
             <a:solidFill>
               <a:srgbClr val="E85D26"/>
             </a:solidFill>
-          </a:ln>
-          <a:ln>
             <a:tailEnd type="arrow" w="med" len="med"/>
           </a:ln>
         </p:spPr>
@@ -22442,8 +22031,6 @@
             <a:solidFill>
               <a:srgbClr val="E85D26"/>
             </a:solidFill>
-          </a:ln>
-          <a:ln>
             <a:tailEnd type="arrow" w="med" len="med"/>
           </a:ln>
         </p:spPr>
@@ -22554,8 +22141,6 @@
             <a:solidFill>
               <a:srgbClr val="E85D26"/>
             </a:solidFill>
-          </a:ln>
-          <a:ln>
             <a:tailEnd type="arrow" w="med" len="med"/>
           </a:ln>
         </p:spPr>

</xml_diff>

<commit_message>
docs: fix LSD dedup parameters and preprocessing flow in slides 8-9
Corrected slide 8 text from the old merge-based criteria (Δangle≤10°,
dist≤8px, gap≤15px) to the actual dedup logic (center_dist<12px AND
Δangle<25° → drop shorter segment). Updated slide 9 LSD flow diagram
to match the real processing order: Gray→CLAHE→binarise+auto-invert→
LSD→dedup→thickness(7-sample median)→length filter/fuse.

Also corrected --fuse CLI help text threshold values in primary_particle.py
(Δangle<15°, overlap≥70%) to match fuse_contours() implementation.

Co-Authored-By: Claude Sonnet 4.6 <noreply@anthropic.com>
</commit_message>
<xml_diff>
--- a/gate_review_precursor.pptx
+++ b/gate_review_precursor.pptx
@@ -24066,7 +24066,7 @@
                 </a:solidFill>
                 <a:latin typeface="맑은 고딕"/>
               </a:rPr>
-              <a:t>▷  LSD 후처리: 방향각 차이 ≤ 10° · 수직 거리 ≤ 8px · 끝점 간격 ≤ 15px 이면 두 선분을 하나로 융합</a:t>
+              <a:t>▷  LSD 중복 제거: 중심 거리 &lt; 12 px  AND  방향각 차이 &lt; 25°  →  짧은 선분 제거 (긴 선분 우선 유지)</a:t>
             </a:r>
           </a:p>
         </p:txBody>
@@ -25376,7 +25376,8 @@
                 <a:latin typeface="맑은 고딕"/>
               </a:rPr>
               <a:t>이진화
-(Otsu/Adaptive)</a:t>
+(Otsu/Adaptive +
+자동 반전)</a:t>
             </a:r>
           </a:p>
         </p:txBody>
@@ -25562,8 +25563,8 @@
                 </a:solidFill>
                 <a:latin typeface="맑은 고딕"/>
               </a:rPr>
-              <a:t>길이 필터
-(≥ 20px)</a:t>
+              <a:t>중복 제거
+(dist&lt;12px, Δang&lt;25°)</a:t>
             </a:r>
           </a:p>
         </p:txBody>
@@ -25656,8 +25657,8 @@
                 </a:solidFill>
                 <a:latin typeface="맑은 고딕"/>
               </a:rPr>
-              <a:t>선분 융합
-(Union-Find)</a:t>
+              <a:t>두께 측정
+(7샘플 중앙값)</a:t>
             </a:r>
           </a:p>
         </p:txBody>
@@ -25750,7 +25751,8 @@
                 </a:solidFill>
                 <a:latin typeface="맑은 고딕"/>
               </a:rPr>
-              <a:t>두께 측정</a:t>
+              <a:t>길이 필터
+(--min_length, 선택: --fuse)</a:t>
             </a:r>
           </a:p>
         </p:txBody>

</xml_diff>

<commit_message>
fix: correct swapped 1차/2차 pipeline labels on slide 6
secondary_measure.py → 2차 입자 (spherical, SAM2 segmentation)
primary_measure.py  → 1차 입자 (acicular/plate, LSD or SAM2)

The labels were exactly reversed, causing the pipeline overview to
attribute the wrong script to each particle type.

Co-Authored-By: Claude Sonnet 4.6 <noreply@anthropic.com>
</commit_message>
<xml_diff>
--- a/gate_review_precursor.pptx
+++ b/gate_review_precursor.pptx
@@ -20784,7 +20784,7 @@
                 </a:solidFill>
                 <a:latin typeface="맑은 고딕"/>
               </a:rPr>
-              <a:t>1차 입자 파이프라인</a:t>
+              <a:t>2차 입자 파이프라인</a:t>
             </a:r>
           </a:p>
           <a:p>
@@ -21526,7 +21526,7 @@
                 </a:solidFill>
                 <a:latin typeface="맑은 고딕"/>
               </a:rPr>
-              <a:t>2차 입자 파이프라인</a:t>
+              <a:t>1차 입자 파이프라인</a:t>
             </a:r>
           </a:p>
           <a:p>

</xml_diff>

<commit_message>
fix: replace non-existent --preset flag with actual CLI usage in slide 10
--preset acicular_20k / --preset secondary_20k do not exist.
Real usage is --particle_type acicular --magnification 20k (primary)
and --magnification 20k (secondary). Also corrected which script
handles which particle type per the PPTX's domain convention.

Co-Authored-By: Claude Sonnet 4.6 <noreply@anthropic.com>
</commit_message>
<xml_diff>
--- a/gate_review_precursor.pptx
+++ b/gate_review_precursor.pptx
@@ -4190,7 +4190,7 @@
                 </a:solidFill>
                 <a:latin typeface="맑은 고딕"/>
               </a:rPr>
-              <a:t>▪  1차 입자 분석 실행</a:t>
+              <a:t>▪  1차 입자 분석 실행 (구형도 · 등가직경)</a:t>
             </a:r>
           </a:p>
           <a:p>
@@ -4206,7 +4206,7 @@
                 </a:solidFill>
                 <a:latin typeface="맑은 고딕"/>
               </a:rPr>
-              <a:t>    –  python primary_measure.py --input [경로]</a:t>
+              <a:t>    –  python secondary_measure.py --input [경로]</a:t>
             </a:r>
           </a:p>
           <a:p>
@@ -4222,7 +4222,7 @@
                 </a:solidFill>
                 <a:latin typeface="맑은 고딕"/>
               </a:rPr>
-              <a:t>    –    --preset acicular_20k</a:t>
+              <a:t>    –    --magnification 20k</a:t>
             </a:r>
           </a:p>
           <a:p>
@@ -4238,7 +4238,7 @@
                 </a:solidFill>
                 <a:latin typeface="맑은 고딕"/>
               </a:rPr>
-              <a:t>▪  2차 입자 분석 실행</a:t>
+              <a:t>▪  2차 입자 분석 실행 (두께 · 종횡비)</a:t>
             </a:r>
           </a:p>
           <a:p>
@@ -4254,7 +4254,7 @@
                 </a:solidFill>
                 <a:latin typeface="맑은 고딕"/>
               </a:rPr>
-              <a:t>    –  python secondary_measure.py --input [경로]</a:t>
+              <a:t>    –  python primary_measure.py --input [경로]</a:t>
             </a:r>
           </a:p>
           <a:p>
@@ -4270,7 +4270,7 @@
                 </a:solidFill>
                 <a:latin typeface="맑은 고딕"/>
               </a:rPr>
-              <a:t>    –    --preset secondary_20k</a:t>
+              <a:t>    –    --particle_type acicular --magnification 20k</a:t>
             </a:r>
           </a:p>
           <a:p>

</xml_diff>